<commit_message>
Pricing principles: drop list-price and settlement items; five principles in deck and memo.
Steering HTML/PPTX use a 3+2 card layout; subtitles and discussion copy updated. Add build_pricing_principles_docx.py for doc parity.

Made-with: Cursor
</commit_message>
<xml_diff>
--- a/pos-pricing-model/steering-committee-deck.pptx
+++ b/pos-pricing-model/steering-committee-deck.pptx
@@ -8078,7 +8078,7 @@
               </a:defRPr>
             </a:pPr>
             <a:r>
-              <a:t>North star: physical GMV and PDV revenue — keep the bill legible, list anchors honest to the market, and settlement + bundle economics visible where deals get made.</a:t>
+              <a:t>North star: physical GMV and PDV revenue — keep bills legible for merchants, and track repricing, conversion, and PoS + payments economics together.</a:t>
             </a:r>
           </a:p>
         </p:txBody>
@@ -8092,7 +8092,7 @@
         <p:spPr>
           <a:xfrm>
             <a:off x="457200" y="1627632"/>
-            <a:ext cx="2750743" cy="1938528"/>
+            <a:ext cx="3698138" cy="1938528"/>
           </a:xfrm>
           <a:prstGeom prst="rect">
             <a:avLst/>
@@ -8137,7 +8137,7 @@
         <p:spPr>
           <a:xfrm>
             <a:off x="548640" y="1691640"/>
-            <a:ext cx="2567863" cy="1828800"/>
+            <a:ext cx="3515258" cy="1828800"/>
           </a:xfrm>
           <a:prstGeom prst="rect">
             <a:avLst/>
@@ -8194,8 +8194,8 @@
         </p:nvSpPr>
         <p:spPr>
           <a:xfrm>
-            <a:off x="3299383" y="1627632"/>
-            <a:ext cx="2750743" cy="1938528"/>
+            <a:off x="4246778" y="1627632"/>
+            <a:ext cx="3698138" cy="1938528"/>
           </a:xfrm>
           <a:prstGeom prst="rect">
             <a:avLst/>
@@ -8239,8 +8239,8 @@
         </p:nvSpPr>
         <p:spPr>
           <a:xfrm>
-            <a:off x="3390823" y="1691640"/>
-            <a:ext cx="2567863" cy="1828800"/>
+            <a:off x="4338218" y="1691640"/>
+            <a:ext cx="3515258" cy="1828800"/>
           </a:xfrm>
           <a:prstGeom prst="rect">
             <a:avLst/>
@@ -8297,8 +8297,8 @@
         </p:nvSpPr>
         <p:spPr>
           <a:xfrm>
-            <a:off x="6141567" y="1627632"/>
-            <a:ext cx="2750743" cy="1938528"/>
+            <a:off x="8036356" y="1627632"/>
+            <a:ext cx="3698138" cy="1938528"/>
           </a:xfrm>
           <a:prstGeom prst="rect">
             <a:avLst/>
@@ -8342,8 +8342,8 @@
         </p:nvSpPr>
         <p:spPr>
           <a:xfrm>
-            <a:off x="6233007" y="1691640"/>
-            <a:ext cx="2567863" cy="1828800"/>
+            <a:off x="8127796" y="1691640"/>
+            <a:ext cx="3515258" cy="1828800"/>
           </a:xfrm>
           <a:prstGeom prst="rect">
             <a:avLst/>
@@ -8400,8 +8400,8 @@
         </p:nvSpPr>
         <p:spPr>
           <a:xfrm>
-            <a:off x="8983751" y="1627632"/>
-            <a:ext cx="2750743" cy="1938528"/>
+            <a:off x="457200" y="3657600"/>
+            <a:ext cx="5592927" cy="1938528"/>
           </a:xfrm>
           <a:prstGeom prst="rect">
             <a:avLst/>
@@ -8445,8 +8445,8 @@
         </p:nvSpPr>
         <p:spPr>
           <a:xfrm>
-            <a:off x="9075191" y="1691640"/>
-            <a:ext cx="2567863" cy="1828800"/>
+            <a:off x="548640" y="3721608"/>
+            <a:ext cx="5410047" cy="1828800"/>
           </a:xfrm>
           <a:prstGeom prst="rect">
             <a:avLst/>
@@ -8471,7 +8471,7 @@
               </a:defRPr>
             </a:pPr>
             <a:r>
-              <a:t>4  📊  Ground list prices in non-promotional market bands</a:t>
+              <a:t>4  📈  Monitor repricing and conversion jointly</a:t>
             </a:r>
           </a:p>
           <a:p>
@@ -8490,7 +8490,7 @@
               </a:defRPr>
             </a:pPr>
             <a:r>
-              <a:t>Sustainable benchmarks; promos distort comparability.</a:t>
+              <a:t>Price = product surface; watch funnel &amp; tickets by segment.</a:t>
             </a:r>
           </a:p>
         </p:txBody>
@@ -8503,8 +8503,8 @@
         </p:nvSpPr>
         <p:spPr>
           <a:xfrm>
-            <a:off x="457200" y="3657600"/>
-            <a:ext cx="3698138" cy="1938528"/>
+            <a:off x="6141567" y="3657600"/>
+            <a:ext cx="5592927" cy="1938528"/>
           </a:xfrm>
           <a:prstGeom prst="rect">
             <a:avLst/>
@@ -8548,8 +8548,8 @@
         </p:nvSpPr>
         <p:spPr>
           <a:xfrm>
-            <a:off x="548640" y="3721608"/>
-            <a:ext cx="3515258" cy="1828800"/>
+            <a:off x="6233007" y="3721608"/>
+            <a:ext cx="5410047" cy="1828800"/>
           </a:xfrm>
           <a:prstGeom prst="rect">
             <a:avLst/>
@@ -8574,7 +8574,7 @@
               </a:defRPr>
             </a:pPr>
             <a:r>
-              <a:t>5  ⏱️  Respect settlement horizon sensitivity</a:t>
+              <a:t>5  🔗  Bundle economics with PoS</a:t>
             </a:r>
           </a:p>
           <a:p>
@@ -8593,212 +8593,6 @@
               </a:defRPr>
             </a:pPr>
             <a:r>
-              <a:t>Prazo/anticipation ↔ effective MDR; surface in CRM.</a:t>
-            </a:r>
-          </a:p>
-        </p:txBody>
-      </p:sp>
-      <p:sp>
-        <p:nvSpPr>
-          <p:cNvPr id="15" name="Rectangle 14"/>
-          <p:cNvSpPr/>
-          <p:nvPr/>
-        </p:nvSpPr>
-        <p:spPr>
-          <a:xfrm>
-            <a:off x="4246778" y="3657600"/>
-            <a:ext cx="3698138" cy="1938528"/>
-          </a:xfrm>
-          <a:prstGeom prst="rect">
-            <a:avLst/>
-          </a:prstGeom>
-          <a:solidFill>
-            <a:srgbClr val="161E34"/>
-          </a:solidFill>
-          <a:ln w="12700">
-            <a:solidFill>
-              <a:srgbClr val="5A6480"/>
-            </a:solidFill>
-          </a:ln>
-        </p:spPr>
-        <p:style>
-          <a:lnRef idx="1">
-            <a:schemeClr val="accent1"/>
-          </a:lnRef>
-          <a:fillRef idx="3">
-            <a:schemeClr val="accent1"/>
-          </a:fillRef>
-          <a:effectRef idx="2">
-            <a:schemeClr val="accent1"/>
-          </a:effectRef>
-          <a:fontRef idx="minor">
-            <a:schemeClr val="lt1"/>
-          </a:fontRef>
-        </p:style>
-        <p:txBody>
-          <a:bodyPr rtlCol="0" anchor="ctr"/>
-          <a:lstStyle/>
-          <a:p>
-            <a:pPr algn="ctr"/>
-          </a:p>
-        </p:txBody>
-      </p:sp>
-      <p:sp>
-        <p:nvSpPr>
-          <p:cNvPr id="16" name="TextBox 15"/>
-          <p:cNvSpPr txBox="1"/>
-          <p:nvPr/>
-        </p:nvSpPr>
-        <p:spPr>
-          <a:xfrm>
-            <a:off x="4338218" y="3721608"/>
-            <a:ext cx="3515258" cy="1828800"/>
-          </a:xfrm>
-          <a:prstGeom prst="rect">
-            <a:avLst/>
-          </a:prstGeom>
-          <a:noFill/>
-        </p:spPr>
-        <p:txBody>
-          <a:bodyPr wrap="square" anchor="t" bIns="0" tIns="0">
-            <a:spAutoFit/>
-          </a:bodyPr>
-          <a:lstStyle/>
-          <a:p>
-            <a:pPr>
-              <a:lnSpc>
-                <a:spcPct val="112000"/>
-              </a:lnSpc>
-              <a:defRPr sz="1200" b="1">
-                <a:solidFill>
-                  <a:srgbClr val="E8ECF0"/>
-                </a:solidFill>
-                <a:latin typeface="Montserrat"/>
-              </a:defRPr>
-            </a:pPr>
-            <a:r>
-              <a:t>6  📈  Monitor repricing and conversion jointly</a:t>
-            </a:r>
-          </a:p>
-          <a:p>
-            <a:pPr>
-              <a:lnSpc>
-                <a:spcPct val="115000"/>
-              </a:lnSpc>
-              <a:spcBef>
-                <a:spcPts val="700"/>
-              </a:spcBef>
-              <a:defRPr sz="1100">
-                <a:solidFill>
-                  <a:srgbClr val="9CA3AF"/>
-                </a:solidFill>
-                <a:latin typeface="Roboto"/>
-              </a:defRPr>
-            </a:pPr>
-            <a:r>
-              <a:t>Price = product surface; watch funnel &amp; tickets by segment.</a:t>
-            </a:r>
-          </a:p>
-        </p:txBody>
-      </p:sp>
-      <p:sp>
-        <p:nvSpPr>
-          <p:cNvPr id="17" name="Rectangle 16"/>
-          <p:cNvSpPr/>
-          <p:nvPr/>
-        </p:nvSpPr>
-        <p:spPr>
-          <a:xfrm>
-            <a:off x="8036356" y="3657600"/>
-            <a:ext cx="3698138" cy="1938528"/>
-          </a:xfrm>
-          <a:prstGeom prst="rect">
-            <a:avLst/>
-          </a:prstGeom>
-          <a:solidFill>
-            <a:srgbClr val="161E34"/>
-          </a:solidFill>
-          <a:ln w="12700">
-            <a:solidFill>
-              <a:srgbClr val="5A6480"/>
-            </a:solidFill>
-          </a:ln>
-        </p:spPr>
-        <p:style>
-          <a:lnRef idx="1">
-            <a:schemeClr val="accent1"/>
-          </a:lnRef>
-          <a:fillRef idx="3">
-            <a:schemeClr val="accent1"/>
-          </a:fillRef>
-          <a:effectRef idx="2">
-            <a:schemeClr val="accent1"/>
-          </a:effectRef>
-          <a:fontRef idx="minor">
-            <a:schemeClr val="lt1"/>
-          </a:fontRef>
-        </p:style>
-        <p:txBody>
-          <a:bodyPr rtlCol="0" anchor="ctr"/>
-          <a:lstStyle/>
-          <a:p>
-            <a:pPr algn="ctr"/>
-          </a:p>
-        </p:txBody>
-      </p:sp>
-      <p:sp>
-        <p:nvSpPr>
-          <p:cNvPr id="18" name="TextBox 17"/>
-          <p:cNvSpPr txBox="1"/>
-          <p:nvPr/>
-        </p:nvSpPr>
-        <p:spPr>
-          <a:xfrm>
-            <a:off x="8127796" y="3721608"/>
-            <a:ext cx="3515258" cy="1828800"/>
-          </a:xfrm>
-          <a:prstGeom prst="rect">
-            <a:avLst/>
-          </a:prstGeom>
-          <a:noFill/>
-        </p:spPr>
-        <p:txBody>
-          <a:bodyPr wrap="square" anchor="t" bIns="0" tIns="0">
-            <a:spAutoFit/>
-          </a:bodyPr>
-          <a:lstStyle/>
-          <a:p>
-            <a:pPr>
-              <a:lnSpc>
-                <a:spcPct val="112000"/>
-              </a:lnSpc>
-              <a:defRPr sz="1200" b="1">
-                <a:solidFill>
-                  <a:srgbClr val="E8ECF0"/>
-                </a:solidFill>
-                <a:latin typeface="Montserrat"/>
-              </a:defRPr>
-            </a:pPr>
-            <a:r>
-              <a:t>7  🔗  Bundle economics with PoS</a:t>
-            </a:r>
-          </a:p>
-          <a:p>
-            <a:pPr>
-              <a:lnSpc>
-                <a:spcPct val="115000"/>
-              </a:lnSpc>
-              <a:spcBef>
-                <a:spcPts val="700"/>
-              </a:spcBef>
-              <a:defRPr sz="1100">
-                <a:solidFill>
-                  <a:srgbClr val="9CA3AF"/>
-                </a:solidFill>
-                <a:latin typeface="Roboto"/>
-              </a:defRPr>
-            </a:pPr>
-            <a:r>
               <a:t>Payments on physical GMV + PoS SaaS — not either line alone.</a:t>
             </a:r>
           </a:p>
@@ -8806,7 +8600,7 @@
       </p:sp>
       <p:sp>
         <p:nvSpPr>
-          <p:cNvPr id="19" name="TextBox 18"/>
+          <p:cNvPr id="15" name="TextBox 14"/>
           <p:cNvSpPr txBox="1"/>
           <p:nvPr/>
         </p:nvSpPr>
@@ -9372,7 +9166,7 @@
               </a:defRPr>
             </a:pPr>
             <a:r>
-              <a:t>North star: offline GMV &amp; revenue. We still want NOTR guardrails, non-promo list anchors, settlement visible in quoting, and a repricing loop — but perfect economics on every segment often requires more granularity than a single simple facade.</a:t>
+              <a:t>North star: offline GMV &amp; revenue. We still want NOTR guardrails, a repricing loop, and segment fidelity in quotes — but perfect economics on every segment often requires more granularity than a single simple facade.</a:t>
             </a:r>
           </a:p>
         </p:txBody>

</xml_diff>